<commit_message>
Reschedule Workshop 1 for a single trainer: sequential, compressed tracks
Track A 13:30-15:00 (Ex01/02/06/07 hands-on, Ex03-05 and Ex09 as
instructor demos, Ex08 briefed as post-workshop solo work), break,
Track B 15:15-16:45 (2D talk+lab, then 3D talk+lab). Closing
unchanged at 16:45. Updated both agendas, both Track A/B lab guides
and the affected deck slides, in Turkish and English.

Co-Authored-By: Claude Fable 5 <noreply@anthropic.com>
</commit_message>
<xml_diff>
--- a/atolye_icerik/sunumlar/01_acilis_temeller.pptx
+++ b/atolye_icerik/sunumlar/01_acilis_temeller.pptx
@@ -2678,7 +2678,7 @@
                           <a:ea typeface="Arial" pitchFamily="34" charset="-122"/>
                           <a:cs typeface="Arial" pitchFamily="34" charset="-120"/>
                         </a:rPr>
-                        <a:t>13:30 – 16:45</a:t>
+                        <a:t>13:30 – 15:00</a:t>
                       </a:r>
                       <a:endParaRPr lang="en-US" sz="1150" dirty="0">
                         <a:latin typeface="Arial" charset="0"/>
@@ -2884,7 +2884,7 @@
                           <a:ea typeface="Arial" pitchFamily="34" charset="-122"/>
                           <a:cs typeface="Arial" pitchFamily="34" charset="-120"/>
                         </a:rPr>
-                        <a:t>13:30 – 16:45</a:t>
+                        <a:t>15:15 – 16:45</a:t>
                       </a:r>
                       <a:endParaRPr lang="en-US" sz="1150" dirty="0">
                         <a:latin typeface="Arial" charset="0"/>

</xml_diff>